<commit_message>
feat(platform): release CISRE 5.6.0 plugin harness
</commit_message>
<xml_diff>
--- a/docs/CISRE_ENTERPRISE_OPS_PLATFORM.pptx
+++ b/docs/CISRE_ENTERPRISE_OPS_PLATFORM.pptx
@@ -2,30 +2,30 @@
 <file path=ppt/presentation.xml><?xml version="1.0" encoding="utf-8"?>
 <p:presentation xmlns:p="http://schemas.openxmlformats.org/presentationml/2006/main">
   <p:sldMasterIdLst>
-    <p:sldMasterId xmlns:r="http://schemas.openxmlformats.org/officeDocument/2006/relationships" id="2147483648" r:id="Re9e0cc8c48924ace"/>
+    <p:sldMasterId xmlns:r="http://schemas.openxmlformats.org/officeDocument/2006/relationships" id="2147483648" r:id="R427a89c408be4ca6"/>
   </p:sldMasterIdLst>
   <p:notesMasterIdLst>
-    <p:notesMasterId xmlns:r="http://schemas.openxmlformats.org/officeDocument/2006/relationships" r:id="Re15fa6804a1049ef"/>
+    <p:notesMasterId xmlns:r="http://schemas.openxmlformats.org/officeDocument/2006/relationships" r:id="Rdd4588b1468e46cc"/>
   </p:notesMasterIdLst>
   <p:sldIdLst>
-    <p:sldId xmlns:r="http://schemas.openxmlformats.org/officeDocument/2006/relationships" id="256" r:id="R0a32dd25867d4861"/>
-    <p:sldId xmlns:r="http://schemas.openxmlformats.org/officeDocument/2006/relationships" id="257" r:id="R2058d98a78fc46ba"/>
-    <p:sldId xmlns:r="http://schemas.openxmlformats.org/officeDocument/2006/relationships" id="258" r:id="Rf68e11672090430b"/>
-    <p:sldId xmlns:r="http://schemas.openxmlformats.org/officeDocument/2006/relationships" id="259" r:id="R1a3b5ec481a14fbe"/>
-    <p:sldId xmlns:r="http://schemas.openxmlformats.org/officeDocument/2006/relationships" id="260" r:id="Rb76793c8928f455e"/>
-    <p:sldId xmlns:r="http://schemas.openxmlformats.org/officeDocument/2006/relationships" id="261" r:id="R27958d3d5ee4491c"/>
-    <p:sldId xmlns:r="http://schemas.openxmlformats.org/officeDocument/2006/relationships" id="262" r:id="Ra192a914358f4d36"/>
-    <p:sldId xmlns:r="http://schemas.openxmlformats.org/officeDocument/2006/relationships" id="263" r:id="R2cfbd77e2ca04324"/>
-    <p:sldId xmlns:r="http://schemas.openxmlformats.org/officeDocument/2006/relationships" id="264" r:id="Rdc64a5a0ecbd49f3"/>
-    <p:sldId xmlns:r="http://schemas.openxmlformats.org/officeDocument/2006/relationships" id="265" r:id="R406f19cd4870462f"/>
-    <p:sldId xmlns:r="http://schemas.openxmlformats.org/officeDocument/2006/relationships" id="266" r:id="R80488878fa464db3"/>
-    <p:sldId xmlns:r="http://schemas.openxmlformats.org/officeDocument/2006/relationships" id="267" r:id="R4a49db2090134a5c"/>
-    <p:sldId xmlns:r="http://schemas.openxmlformats.org/officeDocument/2006/relationships" id="268" r:id="R618b17f9b5aa417b"/>
-    <p:sldId xmlns:r="http://schemas.openxmlformats.org/officeDocument/2006/relationships" id="269" r:id="Rc58a2d656dc14b9b"/>
-    <p:sldId xmlns:r="http://schemas.openxmlformats.org/officeDocument/2006/relationships" id="270" r:id="R3722eefb31bb411c"/>
-    <p:sldId xmlns:r="http://schemas.openxmlformats.org/officeDocument/2006/relationships" id="271" r:id="R8a4e765d6b9249dd"/>
-    <p:sldId xmlns:r="http://schemas.openxmlformats.org/officeDocument/2006/relationships" id="272" r:id="Rb555338e752c4fb3"/>
-    <p:sldId xmlns:r="http://schemas.openxmlformats.org/officeDocument/2006/relationships" id="273" r:id="Rc7b877ffa52f4ad1"/>
+    <p:sldId xmlns:r="http://schemas.openxmlformats.org/officeDocument/2006/relationships" id="256" r:id="Rc86c3ec8a2814d30"/>
+    <p:sldId xmlns:r="http://schemas.openxmlformats.org/officeDocument/2006/relationships" id="257" r:id="R6f3dfab23cdc46e2"/>
+    <p:sldId xmlns:r="http://schemas.openxmlformats.org/officeDocument/2006/relationships" id="258" r:id="Rffd166f70a8c400b"/>
+    <p:sldId xmlns:r="http://schemas.openxmlformats.org/officeDocument/2006/relationships" id="259" r:id="R61266e4b51a54e6f"/>
+    <p:sldId xmlns:r="http://schemas.openxmlformats.org/officeDocument/2006/relationships" id="260" r:id="R90bceab2c3fa43af"/>
+    <p:sldId xmlns:r="http://schemas.openxmlformats.org/officeDocument/2006/relationships" id="261" r:id="R201193b5a5024d9d"/>
+    <p:sldId xmlns:r="http://schemas.openxmlformats.org/officeDocument/2006/relationships" id="262" r:id="R6fa90b939f554253"/>
+    <p:sldId xmlns:r="http://schemas.openxmlformats.org/officeDocument/2006/relationships" id="263" r:id="R8e51be94a5424b53"/>
+    <p:sldId xmlns:r="http://schemas.openxmlformats.org/officeDocument/2006/relationships" id="264" r:id="R0b9fb61e685947e1"/>
+    <p:sldId xmlns:r="http://schemas.openxmlformats.org/officeDocument/2006/relationships" id="265" r:id="R95addb10c5de415a"/>
+    <p:sldId xmlns:r="http://schemas.openxmlformats.org/officeDocument/2006/relationships" id="266" r:id="R31692506300245e8"/>
+    <p:sldId xmlns:r="http://schemas.openxmlformats.org/officeDocument/2006/relationships" id="267" r:id="R639d19798dd94c50"/>
+    <p:sldId xmlns:r="http://schemas.openxmlformats.org/officeDocument/2006/relationships" id="268" r:id="R4abe32645f4d44b8"/>
+    <p:sldId xmlns:r="http://schemas.openxmlformats.org/officeDocument/2006/relationships" id="269" r:id="R616db9b89c9d47e1"/>
+    <p:sldId xmlns:r="http://schemas.openxmlformats.org/officeDocument/2006/relationships" id="270" r:id="R75440701006d47e3"/>
+    <p:sldId xmlns:r="http://schemas.openxmlformats.org/officeDocument/2006/relationships" id="271" r:id="R91ec229d0b7d43f0"/>
+    <p:sldId xmlns:r="http://schemas.openxmlformats.org/officeDocument/2006/relationships" id="272" r:id="R66317f9114484931"/>
+    <p:sldId xmlns:r="http://schemas.openxmlformats.org/officeDocument/2006/relationships" id="273" r:id="Ra23f23572e5b4cfb"/>
   </p:sldIdLst>
   <p:sldSz cx="12192000" cy="6858000"/>
   <p:notesSz cx="6858000" cy="9144000"/>
@@ -523,7 +523,21 @@
         <p:txBody>
           <a:bodyPr xmlns:a="http://schemas.openxmlformats.org/drawingml/2006/main"/>
           <a:lstStyle xmlns:a="http://schemas.openxmlformats.org/drawingml/2006/main"/>
-          <a:p xmlns:a="http://schemas.openxmlformats.org/drawingml/2006/main"/>
+          <a:p xmlns:a="http://schemas.openxmlformats.org/drawingml/2006/main">
+            <a:r>
+              <a:t>[Sources]</a:t>
+            </a:r>
+          </a:p>
+          <a:p xmlns:a="http://schemas.openxmlformats.org/drawingml/2006/main">
+            <a:r>
+              <a:t>- https://raw.githubusercontent.com/deepseek-ai/deepseek-harness/master/docs/architecture.md</a:t>
+            </a:r>
+          </a:p>
+          <a:p xmlns:a="http://schemas.openxmlformats.org/drawingml/2006/main">
+            <a:r>
+              <a:t>[/Sources]</a:t>
+            </a:r>
+          </a:p>
         </p:txBody>
       </p:sp>
       <p:sp>
@@ -1513,7 +1527,26 @@
         <p:txBody>
           <a:bodyPr xmlns:a="http://schemas.openxmlformats.org/drawingml/2006/main"/>
           <a:lstStyle xmlns:a="http://schemas.openxmlformats.org/drawingml/2006/main"/>
-          <a:p xmlns:a="http://schemas.openxmlformats.org/drawingml/2006/main"/>
+          <a:p xmlns:a="http://schemas.openxmlformats.org/drawingml/2006/main">
+            <a:r>
+              <a:t>[Sources]</a:t>
+            </a:r>
+          </a:p>
+          <a:p xmlns:a="http://schemas.openxmlformats.org/drawingml/2006/main">
+            <a:r>
+              <a:t>- https://github.com/deepseek-ai/deepseek-harness</a:t>
+            </a:r>
+          </a:p>
+          <a:p xmlns:a="http://schemas.openxmlformats.org/drawingml/2006/main">
+            <a:r>
+              <a:t>- https://raw.githubusercontent.com/deepseek-ai/deepseek-harness/master/README.md</a:t>
+            </a:r>
+          </a:p>
+          <a:p xmlns:a="http://schemas.openxmlformats.org/drawingml/2006/main">
+            <a:r>
+              <a:t>[/Sources]</a:t>
+            </a:r>
+          </a:p>
         </p:txBody>
       </p:sp>
       <p:sp>
@@ -1579,7 +1612,26 @@
         <p:txBody>
           <a:bodyPr xmlns:a="http://schemas.openxmlformats.org/drawingml/2006/main"/>
           <a:lstStyle xmlns:a="http://schemas.openxmlformats.org/drawingml/2006/main"/>
-          <a:p xmlns:a="http://schemas.openxmlformats.org/drawingml/2006/main"/>
+          <a:p xmlns:a="http://schemas.openxmlformats.org/drawingml/2006/main">
+            <a:r>
+              <a:t>[Sources]</a:t>
+            </a:r>
+          </a:p>
+          <a:p xmlns:a="http://schemas.openxmlformats.org/drawingml/2006/main">
+            <a:r>
+              <a:t>- https://raw.githubusercontent.com/deepseek-ai/deepseek-harness/master/docs/architecture.md</a:t>
+            </a:r>
+          </a:p>
+          <a:p xmlns:a="http://schemas.openxmlformats.org/drawingml/2006/main">
+            <a:r>
+              <a:t>- https://github.com/deepseek-ai/deepseek-harness</a:t>
+            </a:r>
+          </a:p>
+          <a:p xmlns:a="http://schemas.openxmlformats.org/drawingml/2006/main">
+            <a:r>
+              <a:t>[/Sources]</a:t>
+            </a:r>
+          </a:p>
         </p:txBody>
       </p:sp>
       <p:sp>
@@ -1645,7 +1697,7 @@
   </p:cSld>
   <p:clrMap bg1="lt1" tx1="dk1" bg2="lt2" tx2="dk2" accent1="accent1" accent2="accent2" accent3="accent3" accent4="accent4" accent5="accent5" accent6="accent6" hlink="hlink" folHlink="folHlink"/>
   <p:sldLayoutIdLst>
-    <p:sldLayoutId xmlns:r="http://schemas.openxmlformats.org/officeDocument/2006/relationships" id="2147483649" r:id="R93ba7cca223045ec"/>
+    <p:sldLayoutId xmlns:r="http://schemas.openxmlformats.org/officeDocument/2006/relationships" id="2147483649" r:id="Rfdef31f47c5642bb"/>
   </p:sldLayoutIdLst>
   <p:txStyles>
     <p:titleStyle>
@@ -2690,7 +2742,7 @@
                 <a:ea typeface="Microsoft YaHei"/>
                 <a:cs typeface="Microsoft YaHei"/>
               </a:rPr>
-              <a:t>CISRE 5.5.1 以插件、Skill 与受控执行面连接 Kubernetes、数据库、VM、存储、中间件、云资源和网络。</a:t>
+              <a:t>CISRE 5.6.0 以 Harness 插件服务、Skill 与受控执行面统一连接七类基础设施。</a:t>
             </a:r>
           </a:p>
         </p:txBody>
@@ -3223,7 +3275,7 @@
                 <a:ea typeface="Microsoft YaHei"/>
                 <a:cs typeface="Microsoft YaHei"/>
               </a:rPr>
-              <a:t>每个插件都是可发现、可组合、可治理的服务提供者</a:t>
+              <a:t>团队只维护插件，核心负责编排与治理</a:t>
             </a:r>
           </a:p>
         </p:txBody>
@@ -3572,7 +3624,7 @@
                 <a:ea typeface="Microsoft YaHei"/>
                 <a:cs typeface="Microsoft YaHei"/>
               </a:rPr>
-              <a:t>ID / SemVer / Owner</a:t>
+              <a:t>ID / SemVer / Owner / Domain</a:t>
             </a:r>
           </a:p>
           <a:p xmlns:a="http://schemas.openxmlformats.org/drawingml/2006/main">
@@ -3599,7 +3651,7 @@
                 <a:ea typeface="Microsoft YaHei"/>
                 <a:cs typeface="Microsoft YaHei"/>
               </a:rPr>
-              <a:t>Provides / Requires</a:t>
+              <a:t>Agent / Provides / Requires</a:t>
             </a:r>
           </a:p>
           <a:p xmlns:a="http://schemas.openxmlformats.org/drawingml/2006/main">
@@ -3845,7 +3897,7 @@
                 <a:ea typeface="Microsoft YaHei"/>
                 <a:cs typeface="Microsoft YaHei"/>
               </a:rPr>
-              <a:t>依赖解析与启动顺序</a:t>
+              <a:t>依赖与版本解析</a:t>
             </a:r>
           </a:p>
           <a:p xmlns:a="http://schemas.openxmlformats.org/drawingml/2006/main">
@@ -3872,7 +3924,7 @@
                 <a:ea typeface="Microsoft YaHei"/>
                 <a:cs typeface="Microsoft YaHei"/>
               </a:rPr>
-              <a:t>Provider 选择与作用域</a:t>
+              <a:t>Callable Provider 选择</a:t>
             </a:r>
           </a:p>
           <a:p xmlns:a="http://schemas.openxmlformats.org/drawingml/2006/main">
@@ -4422,7 +4474,7 @@
                 <a:ea typeface="Microsoft YaHei"/>
                 <a:cs typeface="Microsoft YaHei"/>
               </a:rPr>
-              <a:t>其他团队新增能力时只交付插件和 Skill；核心无需增加厂商分支。</a:t>
+              <a:t>前端可一键导出 Provider / Skill / tests / Docker / K8s 完整工程；核心无需增加厂商分支。</a:t>
             </a:r>
           </a:p>
         </p:txBody>
@@ -4736,7 +4788,7 @@
                 <a:ea typeface="Microsoft YaHei"/>
                 <a:cs typeface="Microsoft YaHei"/>
               </a:rPr>
-              <a:t>前端即可理解、创建、校验和追踪插件</a:t>
+              <a:t>插件开发、调用条件与安全边界一目了然</a:t>
             </a:r>
           </a:p>
         </p:txBody>
@@ -5405,7 +5457,7 @@
                 <a:ea typeface="Microsoft YaHei"/>
                 <a:cs typeface="Microsoft YaHei"/>
               </a:rPr>
-              <a:t>最近调用与成功率</a:t>
+              <a:t>最近调用、成功率与成效</a:t>
             </a:r>
           </a:p>
         </p:txBody>
@@ -5882,7 +5934,7 @@
                 <a:ea typeface="Microsoft YaHei"/>
                 <a:cs typeface="Microsoft YaHei"/>
               </a:rPr>
-              <a:t>生成并校验 Manifest</a:t>
+              <a:t>校验并下载完整工程</a:t>
             </a:r>
           </a:p>
         </p:txBody>
@@ -6039,7 +6091,7 @@
                 <a:ea typeface="Microsoft YaHei"/>
                 <a:cs typeface="Microsoft YaHei"/>
               </a:rPr>
-              <a:t>描述目标 → 生成插件草案</a:t>
+              <a:t>描述目标 → 生成 Manifest</a:t>
             </a:r>
           </a:p>
           <a:p xmlns:a="http://schemas.openxmlformats.org/drawingml/2006/main">
@@ -6093,7 +6145,7 @@
                 <a:ea typeface="Microsoft YaHei"/>
                 <a:cs typeface="Microsoft YaHei"/>
               </a:rPr>
-              <a:t>→ 人工调整 Agent Loop / 编排</a:t>
+              <a:t>→ 下载 Provider + Skill 工程</a:t>
             </a:r>
           </a:p>
           <a:p xmlns:a="http://schemas.openxmlformats.org/drawingml/2006/main">
@@ -6120,7 +6172,7 @@
                 <a:ea typeface="Microsoft YaHei"/>
                 <a:cs typeface="Microsoft YaHei"/>
               </a:rPr>
-              <a:t>→ 安装或热重载</a:t>
+              <a:t>→ 沙箱调试 / 安装 / 热重载</a:t>
             </a:r>
           </a:p>
         </p:txBody>
@@ -9096,7 +9148,7 @@
                 <a:ea typeface="Microsoft YaHei"/>
                 <a:cs typeface="Microsoft YaHei"/>
               </a:rPr>
-              <a:t>数据库、VM、存储团队如何接入</a:t>
+              <a:t>每个团队从完整脚手架开始，只补本域能力</a:t>
             </a:r>
           </a:p>
         </p:txBody>
@@ -9445,7 +9497,7 @@
                 <a:ea typeface="Microsoft YaHei"/>
                 <a:cs typeface="Microsoft YaHei"/>
               </a:rPr>
-              <a:t>定义合同</a:t>
+              <a:t>下载工程</a:t>
             </a:r>
           </a:p>
         </p:txBody>
@@ -9507,7 +9559,7 @@
                 <a:ea typeface="Microsoft YaHei"/>
                 <a:cs typeface="Microsoft YaHei"/>
               </a:rPr>
-              <a:t>资源 / 证据 / 验证</a:t>
+              <a:t>Provider / Skill / tests / K8s</a:t>
             </a:r>
           </a:p>
         </p:txBody>
@@ -9699,7 +9751,7 @@
                 <a:ea typeface="Microsoft YaHei"/>
                 <a:cs typeface="Microsoft YaHei"/>
               </a:rPr>
-              <a:t>只读 Provider</a:t>
+              <a:t>实现只读 Provider</a:t>
             </a:r>
           </a:p>
         </p:txBody>
@@ -9761,7 +9813,7 @@
                 <a:ea typeface="Microsoft YaHei"/>
                 <a:cs typeface="Microsoft YaHei"/>
               </a:rPr>
-              <a:t>discover / collect / verify</a:t>
+              <a:t>discover / evidence / verify / propose</a:t>
             </a:r>
           </a:p>
         </p:txBody>
@@ -14839,7 +14891,7 @@
                 <a:ea typeface="Microsoft YaHei"/>
                 <a:cs typeface="Microsoft YaHei"/>
               </a:rPr>
-              <a:t>红线：外置插件不能读取 Secret、直接 mutation、执行任意 Bash/SQL，或绕过审批与 Verifier。</a:t>
+              <a:t>红线：外置插件独立容器、默认只读；不能取 Secret、任意 Bash/SQL、直接 mutation 或绕过审批与 Verifier。</a:t>
             </a:r>
           </a:p>
         </p:txBody>
@@ -17317,7 +17369,7 @@
                 <a:ea typeface="Microsoft YaHei"/>
                 <a:cs typeface="Microsoft YaHei"/>
               </a:rPr>
-              <a:t>K8s 闭环稳态</a:t>
+              <a:t>插件服务可调用</a:t>
             </a:r>
           </a:p>
           <a:p xmlns:a="http://schemas.openxmlformats.org/drawingml/2006/main">
@@ -17344,6 +17396,33 @@
                 <a:ea typeface="Microsoft YaHei"/>
                 <a:cs typeface="Microsoft YaHei"/>
               </a:rPr>
+              <a:t>K8s 闭环 5.6.0</a:t>
+            </a:r>
+          </a:p>
+          <a:p xmlns:a="http://schemas.openxmlformats.org/drawingml/2006/main">
+            <a:pPr algn="l">
+              <a:lnSpc>
+                <a:spcPct val="120000"/>
+              </a:lnSpc>
+              <a:buNone/>
+              <a:defRPr sz="1200" b="0">
+                <a:solidFill>
+                  <a:srgbClr val="5B6B7F"/>
+                </a:solidFill>
+                <a:latin typeface="Microsoft YaHei"/>
+                <a:ea typeface="Microsoft YaHei"/>
+                <a:cs typeface="Microsoft YaHei"/>
+              </a:defRPr>
+            </a:pPr>
+            <a:r>
+              <a:rPr sz="1200" b="0">
+                <a:solidFill>
+                  <a:srgbClr val="5B6B7F"/>
+                </a:solidFill>
+                <a:latin typeface="Microsoft YaHei"/>
+                <a:ea typeface="Microsoft YaHei"/>
+                <a:cs typeface="Microsoft YaHei"/>
+              </a:rPr>
               <a:t>Kernel Port v1</a:t>
             </a:r>
           </a:p>
@@ -17371,34 +17450,7 @@
                 <a:ea typeface="Microsoft YaHei"/>
                 <a:cs typeface="Microsoft YaHei"/>
               </a:rPr>
-              <a:t>审批与完成语义</a:t>
-            </a:r>
-          </a:p>
-          <a:p xmlns:a="http://schemas.openxmlformats.org/drawingml/2006/main">
-            <a:pPr algn="l">
-              <a:lnSpc>
-                <a:spcPct val="120000"/>
-              </a:lnSpc>
-              <a:buNone/>
-              <a:defRPr sz="1200" b="0">
-                <a:solidFill>
-                  <a:srgbClr val="5B6B7F"/>
-                </a:solidFill>
-                <a:latin typeface="Microsoft YaHei"/>
-                <a:ea typeface="Microsoft YaHei"/>
-                <a:cs typeface="Microsoft YaHei"/>
-              </a:defRPr>
-            </a:pPr>
-            <a:r>
-              <a:rPr sz="1200" b="0">
-                <a:solidFill>
-                  <a:srgbClr val="5B6B7F"/>
-                </a:solidFill>
-                <a:latin typeface="Microsoft YaHei"/>
-                <a:ea typeface="Microsoft YaHei"/>
-                <a:cs typeface="Microsoft YaHei"/>
-              </a:rPr>
-              <a:t>合同测试</a:t>
+              <a:t>275 项回归通过</a:t>
             </a:r>
           </a:p>
         </p:txBody>
@@ -17751,7 +17803,7 @@
                 <a:ea typeface="Microsoft YaHei"/>
                 <a:cs typeface="Microsoft YaHei"/>
               </a:rPr>
-              <a:t>DB / VM / 存储 / 中间件 / 网络</a:t>
+              <a:t>DB / VM / 存储 / 中间件 / 云 / 网络</a:t>
             </a:r>
           </a:p>
           <a:p xmlns:a="http://schemas.openxmlformats.org/drawingml/2006/main">
@@ -19076,7 +19128,7 @@
                 <a:ea typeface="Microsoft YaHei"/>
                 <a:cs typeface="Microsoft YaHei"/>
               </a:rPr>
-              <a:t>把分散在各团队的运维经验，</a:t>
+              <a:t>各团队共建领域插件，</a:t>
             </a:r>
           </a:p>
           <a:p xmlns:a="http://schemas.openxmlformats.org/drawingml/2006/main">
@@ -19103,7 +19155,7 @@
                 <a:ea typeface="Microsoft YaHei"/>
                 <a:cs typeface="Microsoft YaHei"/>
               </a:rPr>
-              <a:t>沉淀成可复用、可验证的 CISRE 能力</a:t>
+              <a:t>共同复用企业级 CISRE Harness</a:t>
             </a:r>
           </a:p>
         </p:txBody>
@@ -19262,7 +19314,7 @@
                 <a:ea typeface="Microsoft YaHei"/>
                 <a:cs typeface="Microsoft YaHei"/>
               </a:rPr>
-              <a:t>指定插件 Owner</a:t>
+              <a:t>指定 Plugin Owner</a:t>
             </a:r>
           </a:p>
         </p:txBody>
@@ -19324,7 +19376,7 @@
                 <a:ea typeface="Microsoft YaHei"/>
                 <a:cs typeface="Microsoft YaHei"/>
               </a:rPr>
-              <a:t>负责领域合同、版本与兼容性</a:t>
+              <a:t>负责领域合同、版本、安全与兼容性</a:t>
             </a:r>
           </a:p>
         </p:txBody>
@@ -19483,7 +19535,7 @@
                 <a:ea typeface="Microsoft YaHei"/>
                 <a:cs typeface="Microsoft YaHei"/>
               </a:rPr>
-              <a:t>交付 Provider + Skill</a:t>
+              <a:t>交付插件 + Skills</a:t>
             </a:r>
           </a:p>
         </p:txBody>
@@ -19545,7 +19597,7 @@
                 <a:ea typeface="Microsoft YaHei"/>
                 <a:cs typeface="Microsoft YaHei"/>
               </a:rPr>
-              <a:t>不修改核心，按模板独立迭代</a:t>
+              <a:t>不改核心，按脚手架独立迭代</a:t>
             </a:r>
           </a:p>
         </p:txBody>
@@ -20950,7 +21002,7 @@
                 <a:ea typeface="Microsoft YaHei"/>
                 <a:cs typeface="Microsoft YaHei"/>
               </a:rPr>
-              <a:t>正在形成平台</a:t>
+              <a:t>Harness 已成型</a:t>
             </a:r>
           </a:p>
         </p:txBody>
@@ -21012,7 +21064,7 @@
                 <a:ea typeface="Microsoft YaHei"/>
                 <a:cs typeface="Microsoft YaHei"/>
               </a:rPr>
-              <a:t>稳定 Kernel Port 与版本合同</a:t>
+              <a:t>真实可调用插件服务</a:t>
             </a:r>
           </a:p>
           <a:p xmlns:a="http://schemas.openxmlformats.org/drawingml/2006/main">
@@ -21039,7 +21091,7 @@
                 <a:ea typeface="Microsoft YaHei"/>
                 <a:cs typeface="Microsoft YaHei"/>
               </a:rPr>
-              <a:t>服务依赖与能力模式</a:t>
+              <a:t>Profile / Bundle / Patch</a:t>
             </a:r>
           </a:p>
           <a:p xmlns:a="http://schemas.openxmlformats.org/drawingml/2006/main">
@@ -21066,7 +21118,7 @@
                 <a:ea typeface="Microsoft YaHei"/>
                 <a:cs typeface="Microsoft YaHei"/>
               </a:rPr>
-              <a:t>事件溯源、回放与分支</a:t>
+              <a:t>事件溯源、Trace 与分支</a:t>
             </a:r>
           </a:p>
           <a:p xmlns:a="http://schemas.openxmlformats.org/drawingml/2006/main">
@@ -21093,7 +21145,7 @@
                 <a:ea typeface="Microsoft YaHei"/>
                 <a:cs typeface="Microsoft YaHei"/>
               </a:rPr>
-              <a:t>Agent Trace 与可视化插件工作台</a:t>
+              <a:t>完整插件工程一键导出</a:t>
             </a:r>
           </a:p>
         </p:txBody>
@@ -25682,7 +25734,7 @@
                 <a:ea typeface="Microsoft YaHei"/>
                 <a:cs typeface="Microsoft YaHei"/>
               </a:rPr>
-              <a:t>CISRE 5.5.1 已具备的生产能力</a:t>
+              <a:t>CISRE 5.6.0 已具备的生产能力</a:t>
             </a:r>
           </a:p>
         </p:txBody>
@@ -26799,7 +26851,7 @@
                 <a:ea typeface="Microsoft YaHei"/>
                 <a:cs typeface="Microsoft YaHei"/>
               </a:rPr>
-              <a:t>新 Pod、重启、日志、Events、业务探针</a:t>
+              <a:t>新 Pod、rollout、重启、当前错误、稳定窗口</a:t>
             </a:r>
           </a:p>
         </p:txBody>
@@ -29468,7 +29520,7 @@
                 <a:ea typeface="Microsoft YaHei"/>
                 <a:cs typeface="Microsoft YaHei"/>
               </a:rPr>
-              <a:t>错误消失且稳定</a:t>
+              <a:t>rollout 收敛且稳定</a:t>
             </a:r>
           </a:p>
         </p:txBody>
@@ -29563,7 +29615,7 @@
                 <a:ea typeface="Microsoft YaHei"/>
                 <a:cs typeface="Microsoft YaHei"/>
               </a:rPr>
-              <a:t>关键：变更回执只是执行证据；恢复必须跟随新 revision 的 Pod，并重新读取状态、日志和业务探针。</a:t>
+              <a:t>关键：恢复必须跟随新 revision；旧 Event 或日志通道异常不能覆盖 Ready、rollout 与重启稳定的实时证明。</a:t>
             </a:r>
           </a:p>
         </p:txBody>
@@ -29877,7 +29929,7 @@
                 <a:ea typeface="Microsoft YaHei"/>
                 <a:cs typeface="Microsoft YaHei"/>
               </a:rPr>
-              <a:t>体验层、插件控制面、受控执行面、事实层</a:t>
+              <a:t>可信内核稳定，领域能力通过插件扩展</a:t>
             </a:r>
           </a:p>
         </p:txBody>
@@ -30414,7 +30466,7 @@
                 <a:ea typeface="Microsoft YaHei"/>
                 <a:cs typeface="Microsoft YaHei"/>
               </a:rPr>
-              <a:t>Capability Registry · Agent Loop · Skill Router · Approval Gate · Event Store · Trace</a:t>
+              <a:t>Capability Registry · Callable Services · Agent Loop / Orchestration · Approval · Event / Trace</a:t>
             </a:r>
           </a:p>
         </p:txBody>
@@ -30604,7 +30656,7 @@
                 <a:ea typeface="Microsoft YaHei"/>
                 <a:cs typeface="Microsoft YaHei"/>
               </a:rPr>
-              <a:t>Kubernetes Executor · 领域动作目录 · 同目标回读 · Recovery Verifier</a:t>
+              <a:t>Typed Action · Blast Radius · Approval · Executor · Readback · Recovery Verifier</a:t>
             </a:r>
           </a:p>
         </p:txBody>
@@ -30794,7 +30846,7 @@
                 <a:ea typeface="Microsoft YaHei"/>
                 <a:cs typeface="Microsoft YaHei"/>
               </a:rPr>
-              <a:t>Rancher / kubeconfig · DB / VM / 存储 / 中间件 / 云 / 网络 Provider · Logs / Metrics / Events</a:t>
+              <a:t>Rancher / kubeconfig · 七域 Provider · Logs / Metrics / Events / Trace / CMDB</a:t>
             </a:r>
           </a:p>
         </p:txBody>
@@ -30856,7 +30908,7 @@
                 <a:ea typeface="Microsoft YaHei"/>
                 <a:cs typeface="Microsoft YaHei"/>
               </a:rPr>
-              <a:t>稳定内核只保留状态、权限、审批与完成语义；业务域插件化，存储/队列/租约通过 Port 替换。</a:t>
+              <a:t>Kernel Port v1 固定 Event Journal / Lease / Job Queue / Snapshot；Provider 可替换，完成语义不变。</a:t>
             </a:r>
           </a:p>
         </p:txBody>
@@ -31170,7 +31222,7 @@
                 <a:ea typeface="Microsoft YaHei"/>
                 <a:cs typeface="Microsoft YaHei"/>
               </a:rPr>
-              <a:t>为什么不直接用通用 Harness 替换 CISRE</a:t>
+              <a:t>借鉴通用 Harness，生产控制权留在 CISRE</a:t>
             </a:r>
           </a:p>
         </p:txBody>
@@ -31792,7 +31844,7 @@
                 <a:ea typeface="Microsoft YaHei"/>
                 <a:cs typeface="Microsoft YaHei"/>
               </a:rPr>
-              <a:t>模型不能直接写生产</a:t>
+              <a:t>生产凭据与多域资产</a:t>
             </a:r>
           </a:p>
           <a:p xmlns:a="http://schemas.openxmlformats.org/drawingml/2006/main">
@@ -32127,7 +32179,7 @@
                 <a:ea typeface="Microsoft YaHei"/>
                 <a:cs typeface="Microsoft YaHei"/>
               </a:rPr>
-              <a:t>结论：采用插件内核与编排思想；生产执行权继续由 CISRE 强制治理。</a:t>
+              <a:t>结论：复用插件与编排思想；不重复造通用 Agent 轮子，生产执行权由 CISRE 统一治理。</a:t>
             </a:r>
           </a:p>
         </p:txBody>
@@ -32441,7 +32493,7 @@
                 <a:ea typeface="Microsoft YaHei"/>
                 <a:cs typeface="Microsoft YaHei"/>
               </a:rPr>
-              <a:t>已融合的 Harness 能力与 CISRE 落点</a:t>
+              <a:t>Harness 组合能力已落入 CISRE 生产运行时</a:t>
             </a:r>
           </a:p>
         </p:txBody>
@@ -33038,7 +33090,7 @@
                 <a:ea typeface="Microsoft YaHei"/>
                 <a:cs typeface="Microsoft YaHei"/>
               </a:rPr>
-              <a:t>Capability Registry</a:t>
+              <a:t>真实 Callable Provider</a:t>
             </a:r>
           </a:p>
         </p:txBody>
@@ -33197,7 +33249,7 @@
                 <a:ea typeface="Microsoft YaHei"/>
                 <a:cs typeface="Microsoft YaHei"/>
               </a:rPr>
-              <a:t>local / sandbox / production</a:t>
+              <a:t>Profile / Bundle / Patch</a:t>
             </a:r>
           </a:p>
         </p:txBody>
@@ -33259,7 +33311,7 @@
                 <a:ea typeface="Microsoft YaHei"/>
                 <a:cs typeface="Microsoft YaHei"/>
               </a:rPr>
-              <a:t>权限策略与隔离 Provider</a:t>
+              <a:t>环境可替换 Provider</a:t>
             </a:r>
           </a:p>
         </p:txBody>
@@ -33860,7 +33912,7 @@
                 <a:ea typeface="Microsoft YaHei"/>
                 <a:cs typeface="Microsoft YaHei"/>
               </a:rPr>
-              <a:t>步骤上限、委派、上下文压缩</a:t>
+              <a:t>有界委派、Owner Job、上下文压缩</a:t>
             </a:r>
           </a:p>
         </p:txBody>
@@ -33922,7 +33974,7 @@
                 <a:ea typeface="Microsoft YaHei"/>
                 <a:cs typeface="Microsoft YaHei"/>
               </a:rPr>
-              <a:t>模型规划但无 mutation 权限</a:t>
+              <a:t>子 Agent 只读，mutation 回主审批链</a:t>
             </a:r>
           </a:p>
         </p:txBody>

</xml_diff>